<commit_message>
cai_tien: sửa deck theo review vòng 2
- Slide 4: kéo hình 3-task lên, caption hết bị footer đè (major)
- Slide 9: legend chart BCE sang trái + nới trục, hết đè số 0.54 (major)
- Slide 3: crop lại fig4_arch gọn mép phải (bỏ ký tự lạ)
- Slide 5: crop lại fig2_right hiện đủ nhãn VinDr-Mammo
- Slide 7: bỏ caption chart trùng; Slide 15: 'inference'→'vừa' đồng cột

Co-Authored-By: Claude Opus 4.8 <noreply@anthropic.com>
</commit_message>
<xml_diff>
--- a/seminar/cai_tien/slides_cai_tien_2026-07-05.pptx
+++ b/seminar/cai_tien/slides_cai_tien_2026-07-05.pptx
@@ -9000,7 +9000,7 @@
                           </a:solidFill>
                           <a:latin typeface="Calibri"/>
                         </a:rPr>
-                        <a:t>🟡 inference</a:t>
+                        <a:t>🟡 vừa</a:t>
                       </a:r>
                     </a:p>
                   </a:txBody>
@@ -11375,7 +11375,7 @@
         <p:spPr>
           <a:xfrm>
             <a:off x="5394960" y="2286000"/>
-            <a:ext cx="3611880" cy="1281432"/>
+            <a:ext cx="3611880" cy="1399820"/>
           </a:xfrm>
           <a:prstGeom prst="rect">
             <a:avLst/>
@@ -11390,7 +11390,7 @@
         </p:nvSpPr>
         <p:spPr>
           <a:xfrm>
-            <a:off x="5394960" y="3585720"/>
+            <a:off x="5394960" y="3704107"/>
             <a:ext cx="3611880" cy="320040"/>
           </a:xfrm>
           <a:prstGeom prst="rect">
@@ -11928,8 +11928,8 @@
         </p:blipFill>
         <p:spPr>
           <a:xfrm>
-            <a:off x="1051560" y="3611880"/>
-            <a:ext cx="7040880" cy="1158882"/>
+            <a:off x="1234440" y="3246120"/>
+            <a:ext cx="6675120" cy="1098680"/>
           </a:xfrm>
           <a:prstGeom prst="rect">
             <a:avLst/>
@@ -11944,8 +11944,8 @@
         </p:nvSpPr>
         <p:spPr>
           <a:xfrm>
-            <a:off x="1051560" y="4789049"/>
-            <a:ext cx="7040880" cy="320040"/>
+            <a:off x="1234440" y="4363087"/>
+            <a:ext cx="6675120" cy="320040"/>
           </a:xfrm>
           <a:prstGeom prst="rect">
             <a:avLst/>
@@ -12465,7 +12465,7 @@
         <p:spPr>
           <a:xfrm>
             <a:off x="5760720" y="1508760"/>
-            <a:ext cx="3063240" cy="2523602"/>
+            <a:ext cx="3063240" cy="2379748"/>
           </a:xfrm>
           <a:prstGeom prst="rect">
             <a:avLst/>
@@ -12480,7 +12480,7 @@
         </p:nvSpPr>
         <p:spPr>
           <a:xfrm>
-            <a:off x="5760720" y="4050650"/>
+            <a:off x="5760720" y="3906795"/>
             <a:ext cx="3063240" cy="320040"/>
           </a:xfrm>
           <a:prstGeom prst="rect">
@@ -13688,8 +13688,8 @@
         </p:blipFill>
         <p:spPr>
           <a:xfrm>
-            <a:off x="5669280" y="1389888"/>
-            <a:ext cx="3200400" cy="2556136"/>
+            <a:off x="5669280" y="1527048"/>
+            <a:ext cx="3291840" cy="2629169"/>
           </a:xfrm>
           <a:prstGeom prst="rect">
             <a:avLst/>
@@ -13698,42 +13698,7 @@
       </p:pic>
       <p:sp>
         <p:nvSpPr>
-          <p:cNvPr id="8" name="TextBox 7"/>
-          <p:cNvSpPr txBox="1"/>
-          <p:nvPr/>
-        </p:nvSpPr>
-        <p:spPr>
-          <a:xfrm>
-            <a:off x="5669280" y="3964311"/>
-            <a:ext cx="3200400" cy="320040"/>
-          </a:xfrm>
-          <a:prstGeom prst="rect">
-            <a:avLst/>
-          </a:prstGeom>
-          <a:noFill/>
-        </p:spPr>
-        <p:txBody>
-          <a:bodyPr wrap="square" anchor="t" lIns="25400" rIns="25400" tIns="12700" bIns="12700">
-            <a:spAutoFit/>
-          </a:bodyPr>
-          <a:lstStyle/>
-          <a:p>
-            <a:pPr algn="ctr"/>
-            <a:r>
-              <a:rPr sz="750" b="0" i="1">
-                <a:solidFill>
-                  <a:srgbClr val="6B7F95"/>
-                </a:solidFill>
-                <a:latin typeface="Calibri"/>
-              </a:rPr>
-              <a:t>pIoU: đóng băng vs mở khoá vision</a:t>
-            </a:r>
-          </a:p>
-        </p:txBody>
-      </p:sp>
-      <p:sp>
-        <p:nvSpPr>
-          <p:cNvPr id="9" name="Rectangle 8"/>
+          <p:cNvPr id="8" name="Rectangle 7"/>
           <p:cNvSpPr/>
           <p:nvPr/>
         </p:nvSpPr>
@@ -13777,7 +13742,7 @@
       </p:sp>
       <p:sp>
         <p:nvSpPr>
-          <p:cNvPr id="10" name="TextBox 9"/>
+          <p:cNvPr id="9" name="TextBox 8"/>
           <p:cNvSpPr txBox="1"/>
           <p:nvPr/>
         </p:nvSpPr>
@@ -13811,7 +13776,7 @@
       </p:sp>
       <p:sp>
         <p:nvSpPr>
-          <p:cNvPr id="11" name="TextBox 10"/>
+          <p:cNvPr id="10" name="TextBox 9"/>
           <p:cNvSpPr txBox="1"/>
           <p:nvPr/>
         </p:nvSpPr>

</xml_diff>